<commit_message>
Trim dashboard to short captions; deck cut to 10-slide progress report
Per Paul: the long static explainer boxes were analysis notes that render
identically on every run - 21 cut or reduced to one-line captions across
Overview, Product, Customer, Inventory and Accuracy pages. Data Quality
page keeps its detail deliberately (it is the documentation record) and
Upload page keeps its functional instructions.

Deck: 'fine print' slide removed; dashboard slide now segues into Paul's
live demo; 10 slides.

Co-Authored-By: Claude Opus 5 <noreply@anthropic.com>
</commit_message>
<xml_diff>
--- a/presentation/FY2025_progress_report.pptx
+++ b/presentation/FY2025_progress_report.pptx
@@ -15,10 +15,9 @@
     <p:sldId id="263" r:id="rId9"/>
     <p:sldId id="264" r:id="rId10"/>
     <p:sldId id="265" r:id="rId11"/>
-    <p:sldId id="266" r:id="rId12"/>
   </p:sldIdLst>
   <p:notesMasterIdLst>
-    <p:notesMasterId r:id="rId13"/>
+    <p:notesMasterId r:id="rId12"/>
   </p:notesMasterIdLst>
   <p:sldSz cx="12192000" cy="6858000"/>
   <p:notesSz cx="6858000" cy="12192000"/>
@@ -600,7 +599,7 @@
           <a:p>
             <a:r>
               <a:rPr lang="en-US" dirty="0"/>
-              <a:t>The plan from here. Today: the build is done. At the semi-final on 7 September we present the outcomes - the FY2025 numbers with the accuracy evidence behind them, improved by whatever we take from today's discussion. The final on 28 September delivers the final forecast, the written report, and the handover. (~50s)</a:t>
+              <a:t>To close: the build phase is complete and the data is understood. The numbers and their evidence arrive at the semi-final on 7 September. Now let me show you the dashboard itself, live. (~25s)</a:t>
             </a:r>
             <a:endParaRPr lang="en-US" dirty="0"/>
           </a:p>
@@ -624,94 +623,6 @@
             <a:fld id="{F7021451-1387-4CA6-816F-3879F97B5CBC}" type="slidenum">
               <a:rPr lang="en-US"/>
               <a:t>10</a:t>
-            </a:fld>
-            <a:endParaRPr lang="en-US"/>
-          </a:p>
-        </p:txBody>
-      </p:sp>
-    </p:spTree>
-    <p:extLst>
-      <p:ext uri="{BB962C8B-B14F-4D97-AF65-F5344CB8AC3E}">
-        <p14:creationId xmlns:p14="http://schemas.microsoft.com/office/powerpoint/2010/main" val="1024086991"/>
-      </p:ext>
-    </p:extLst>
-  </p:cSld>
-  <p:clrMapOvr>
-    <a:masterClrMapping/>
-  </p:clrMapOvr>
-</p:notes>
-</file>
-
-<file path=ppt/notesSlides/notesSlide11.xml><?xml version="1.0" encoding="utf-8"?>
-<p:notes xmlns:a="http://schemas.openxmlformats.org/drawingml/2006/main" xmlns:r="http://schemas.openxmlformats.org/officeDocument/2006/relationships" xmlns:p="http://schemas.openxmlformats.org/presentationml/2006/main">
-  <p:cSld>
-    <p:spTree>
-      <p:nvGrpSpPr>
-        <p:cNvPr id="1" name=""/>
-        <p:cNvGrpSpPr/>
-        <p:nvPr/>
-      </p:nvGrpSpPr>
-      <p:grpSpPr>
-        <a:xfrm>
-          <a:off x="0" y="0"/>
-          <a:ext cx="0" cy="0"/>
-          <a:chOff x="0" y="0"/>
-          <a:chExt cx="0" cy="0"/>
-        </a:xfrm>
-      </p:grpSpPr>
-      <p:sp>
-        <p:nvSpPr>
-          <p:cNvPr id="2" name="Slide Image Placeholder 1"/>
-          <p:cNvSpPr>
-            <a:spLocks noGrp="1" noRot="1" noChangeAspect="1"/>
-          </p:cNvSpPr>
-          <p:nvPr>
-            <p:ph type="sldImg"/>
-          </p:nvPr>
-        </p:nvSpPr>
-        <p:spPr/>
-      </p:sp>
-      <p:sp>
-        <p:nvSpPr>
-          <p:cNvPr id="3" name="Notes Placeholder 2"/>
-          <p:cNvSpPr>
-            <a:spLocks noGrp="1"/>
-          </p:cNvSpPr>
-          <p:nvPr>
-            <p:ph type="body" idx="1"/>
-          </p:nvPr>
-        </p:nvSpPr>
-        <p:spPr/>
-        <p:txBody>
-          <a:bodyPr/>
-          <a:lstStyle/>
-          <a:p>
-            <a:r>
-              <a:rPr lang="en-US" dirty="0"/>
-              <a:t>To close: the build phase is complete, the data is understood, and the open questions are on the table. The numbers and their evidence arrive at the semi-final. The dashboard is live if anyone would like to see it now. Thank you. (~30s)</a:t>
-            </a:r>
-            <a:endParaRPr lang="en-US" dirty="0"/>
-          </a:p>
-        </p:txBody>
-      </p:sp>
-      <p:sp>
-        <p:nvSpPr>
-          <p:cNvPr id="4" name="Slide Number Placeholder 3"/>
-          <p:cNvSpPr>
-            <a:spLocks noGrp="1"/>
-          </p:cNvSpPr>
-          <p:nvPr>
-            <p:ph type="sldNum" sz="quarter" idx="10"/>
-          </p:nvPr>
-        </p:nvSpPr>
-        <p:spPr/>
-        <p:txBody>
-          <a:bodyPr/>
-          <a:lstStyle/>
-          <a:p>
-            <a:fld id="{F7021451-1387-4CA6-816F-3879F97B5CBC}" type="slidenum">
-              <a:rPr lang="en-US"/>
-              <a:t>11</a:t>
             </a:fld>
             <a:endParaRPr lang="en-US"/>
           </a:p>
@@ -1216,7 +1127,7 @@
           <a:p>
             <a:r>
               <a:rPr lang="en-US" dirty="0"/>
-              <a:t>The deliverable Mitsubishi's team actually touches. Plain language throughout, every forecast shown next to the evidence behind it, and the key requirement from the brief: anyone can upload a new data file and the entire system re-runs in about two minutes - no code, no analyst. Happy to demo it live afterwards. (~50s)</a:t>
+              <a:t>The deliverable Mitsubishi's team actually touches. Plain language throughout, and the key requirement from the brief: anyone can upload a new data file and the entire system re-runs in about two minutes - no code, no analyst. I will open it live in a moment and walk through it on the real data. (~45s)</a:t>
             </a:r>
             <a:endParaRPr lang="en-US" dirty="0"/>
           </a:p>
@@ -1392,7 +1303,7 @@
           <a:p>
             <a:r>
               <a:rPr lang="en-US" dirty="0"/>
-              <a:t>We read every sheet of the supplied documentation, and it paid off twice. First, the status question resolved itself: Closed means cancelled, and our treatment matches. Second, a genuine open item: the dictionary grants VIP customers 37 percent off, but on identical products VIP and End User pay exactly the same Base Price - so the discount is applied somewhere outside this file. That single answer from Mitsubishi is worth 461 million baht of revenue interpretation. (~55s)</a:t>
+              <a:t>The plan from here. Today: the build is done. At the semi-final on 7 September we present the outcomes - the FY2025 numbers with the accuracy evidence behind them, improved by whatever we take from today's discussion. The final on 28 September delivers the final forecast, the written report, and the handover. (~50s)</a:t>
             </a:r>
             <a:endParaRPr lang="en-US" dirty="0"/>
           </a:p>
@@ -2031,596 +1942,6 @@
     <p:bg>
       <p:bgPr>
         <a:solidFill>
-          <a:srgbClr val="FFFFFF"/>
-        </a:solidFill>
-      </p:bgPr>
-    </p:bg>
-    <p:spTree>
-      <p:nvGrpSpPr>
-        <p:cNvPr id="1" name=""/>
-        <p:cNvGrpSpPr/>
-        <p:nvPr/>
-      </p:nvGrpSpPr>
-      <p:grpSpPr>
-        <a:xfrm>
-          <a:off x="0" y="0"/>
-          <a:ext cx="0" cy="0"/>
-          <a:chOff x="0" y="0"/>
-          <a:chExt cx="0" cy="0"/>
-        </a:xfrm>
-      </p:grpSpPr>
-      <p:sp>
-        <p:nvSpPr>
-          <p:cNvPr id="2" name="Text 0"/>
-          <p:cNvSpPr/>
-          <p:nvPr/>
-        </p:nvSpPr>
-        <p:spPr>
-          <a:xfrm>
-            <a:off x="685800" y="566928"/>
-            <a:ext cx="10817352" cy="274320"/>
-          </a:xfrm>
-          <a:prstGeom prst="rect">
-            <a:avLst/>
-          </a:prstGeom>
-          <a:noFill/>
-          <a:ln/>
-        </p:spPr>
-        <p:txBody>
-          <a:bodyPr wrap="square" lIns="0" tIns="0" rIns="0" bIns="0" rtlCol="0" anchor="ctr"/>
-          <a:lstStyle/>
-          <a:p>
-            <a:pPr algn="l" indent="0" marL="0">
-              <a:buNone/>
-            </a:pPr>
-            <a:r>
-              <a:rPr lang="en-US" sz="1050" b="1" spc="300" kern="0" dirty="0">
-                <a:solidFill>
-                  <a:srgbClr val="6B7280"/>
-                </a:solidFill>
-                <a:latin typeface="Calibri" pitchFamily="34" charset="0"/>
-                <a:ea typeface="Calibri" pitchFamily="34" charset="-122"/>
-                <a:cs typeface="Calibri" pitchFamily="34" charset="-120"/>
-              </a:rPr>
-              <a:t>09 — THE ROAD AHEAD</a:t>
-            </a:r>
-            <a:endParaRPr lang="en-US" sz="1050" dirty="0"/>
-          </a:p>
-        </p:txBody>
-      </p:sp>
-      <p:sp>
-        <p:nvSpPr>
-          <p:cNvPr id="3" name="Text 1"/>
-          <p:cNvSpPr/>
-          <p:nvPr/>
-        </p:nvSpPr>
-        <p:spPr>
-          <a:xfrm>
-            <a:off x="685800" y="914400"/>
-            <a:ext cx="10817352" cy="1051560"/>
-          </a:xfrm>
-          <a:prstGeom prst="rect">
-            <a:avLst/>
-          </a:prstGeom>
-          <a:noFill/>
-          <a:ln/>
-        </p:spPr>
-        <p:txBody>
-          <a:bodyPr wrap="square" lIns="0" tIns="0" rIns="0" bIns="0" rtlCol="0" anchor="ctr"/>
-          <a:lstStyle/>
-          <a:p>
-            <a:pPr algn="l" indent="0" marL="0">
-              <a:buNone/>
-            </a:pPr>
-            <a:r>
-              <a:rPr lang="en-US" sz="3800" b="1" dirty="0">
-                <a:solidFill>
-                  <a:srgbClr val="1C2530"/>
-                </a:solidFill>
-                <a:latin typeface="Cambria" pitchFamily="34" charset="0"/>
-                <a:ea typeface="Cambria" pitchFamily="34" charset="-122"/>
-                <a:cs typeface="Cambria" pitchFamily="34" charset="-120"/>
-              </a:rPr>
-              <a:t>Two milestones to the final forecast.</a:t>
-            </a:r>
-            <a:endParaRPr lang="en-US" sz="3800" dirty="0"/>
-          </a:p>
-        </p:txBody>
-      </p:sp>
-      <p:sp>
-        <p:nvSpPr>
-          <p:cNvPr id="4" name="Shape 2"/>
-          <p:cNvSpPr/>
-          <p:nvPr/>
-        </p:nvSpPr>
-        <p:spPr>
-          <a:xfrm>
-            <a:off x="685800" y="2331720"/>
-            <a:ext cx="3429000" cy="2926080"/>
-          </a:xfrm>
-          <a:prstGeom prst="roundRect">
-            <a:avLst>
-              <a:gd name="adj" fmla="val 2500"/>
-            </a:avLst>
-          </a:prstGeom>
-          <a:solidFill>
-            <a:srgbClr val="1C2530"/>
-          </a:solidFill>
-          <a:ln w="12700">
-            <a:solidFill>
-              <a:srgbClr val="1C2530"/>
-            </a:solidFill>
-            <a:prstDash val="solid"/>
-          </a:ln>
-        </p:spPr>
-      </p:sp>
-      <p:sp>
-        <p:nvSpPr>
-          <p:cNvPr id="5" name="Text 3"/>
-          <p:cNvSpPr/>
-          <p:nvPr/>
-        </p:nvSpPr>
-        <p:spPr>
-          <a:xfrm>
-            <a:off x="1005840" y="2697480"/>
-            <a:ext cx="2788920" cy="320040"/>
-          </a:xfrm>
-          <a:prstGeom prst="rect">
-            <a:avLst/>
-          </a:prstGeom>
-          <a:noFill/>
-          <a:ln/>
-        </p:spPr>
-        <p:txBody>
-          <a:bodyPr wrap="square" lIns="0" tIns="0" rIns="0" bIns="0" rtlCol="0" anchor="ctr"/>
-          <a:lstStyle/>
-          <a:p>
-            <a:pPr indent="0" marL="0">
-              <a:buNone/>
-            </a:pPr>
-            <a:r>
-              <a:rPr lang="en-US" sz="1050" b="1" spc="200" kern="0" dirty="0">
-                <a:solidFill>
-                  <a:srgbClr val="9AA4B0"/>
-                </a:solidFill>
-                <a:latin typeface="Calibri" pitchFamily="34" charset="0"/>
-                <a:ea typeface="Calibri" pitchFamily="34" charset="-122"/>
-                <a:cs typeface="Calibri" pitchFamily="34" charset="-120"/>
-              </a:rPr>
-              <a:t>TODAY — 10 AUG</a:t>
-            </a:r>
-            <a:endParaRPr lang="en-US" sz="1050" dirty="0"/>
-          </a:p>
-        </p:txBody>
-      </p:sp>
-      <p:sp>
-        <p:nvSpPr>
-          <p:cNvPr id="6" name="Text 4"/>
-          <p:cNvSpPr/>
-          <p:nvPr/>
-        </p:nvSpPr>
-        <p:spPr>
-          <a:xfrm>
-            <a:off x="1005840" y="3063240"/>
-            <a:ext cx="2788920" cy="777240"/>
-          </a:xfrm>
-          <a:prstGeom prst="rect">
-            <a:avLst/>
-          </a:prstGeom>
-          <a:noFill/>
-          <a:ln/>
-        </p:spPr>
-        <p:txBody>
-          <a:bodyPr wrap="square" lIns="0" tIns="0" rIns="0" bIns="0" rtlCol="0" anchor="ctr"/>
-          <a:lstStyle/>
-          <a:p>
-            <a:pPr indent="0" marL="0">
-              <a:buNone/>
-            </a:pPr>
-            <a:r>
-              <a:rPr lang="en-US" sz="1900" b="1" dirty="0">
-                <a:solidFill>
-                  <a:srgbClr val="F5F7FA"/>
-                </a:solidFill>
-                <a:latin typeface="Cambria" pitchFamily="34" charset="0"/>
-                <a:ea typeface="Cambria" pitchFamily="34" charset="-122"/>
-                <a:cs typeface="Cambria" pitchFamily="34" charset="-120"/>
-              </a:rPr>
-              <a:t>Progress report</a:t>
-            </a:r>
-            <a:endParaRPr lang="en-US" sz="1900" dirty="0"/>
-          </a:p>
-        </p:txBody>
-      </p:sp>
-      <p:sp>
-        <p:nvSpPr>
-          <p:cNvPr id="7" name="Text 5"/>
-          <p:cNvSpPr/>
-          <p:nvPr/>
-        </p:nvSpPr>
-        <p:spPr>
-          <a:xfrm>
-            <a:off x="1005840" y="3886200"/>
-            <a:ext cx="2788920" cy="1234440"/>
-          </a:xfrm>
-          <a:prstGeom prst="rect">
-            <a:avLst/>
-          </a:prstGeom>
-          <a:noFill/>
-          <a:ln/>
-        </p:spPr>
-        <p:txBody>
-          <a:bodyPr wrap="square" lIns="0" tIns="0" rIns="0" bIns="0" rtlCol="0" anchor="ctr"/>
-          <a:lstStyle/>
-          <a:p>
-            <a:pPr indent="0" marL="0">
-              <a:lnSpc>
-                <a:spcPct val="120000"/>
-              </a:lnSpc>
-              <a:buNone/>
-            </a:pPr>
-            <a:r>
-              <a:rPr lang="en-US" sz="1150" dirty="0">
-                <a:solidFill>
-                  <a:srgbClr val="C9D2DB"/>
-                </a:solidFill>
-                <a:latin typeface="Calibri" pitchFamily="34" charset="0"/>
-                <a:ea typeface="Calibri" pitchFamily="34" charset="-122"/>
-                <a:cs typeface="Calibri" pitchFamily="34" charset="-120"/>
-              </a:rPr>
-              <a:t>system built and running; data understood; questions raised</a:t>
-            </a:r>
-            <a:endParaRPr lang="en-US" sz="1150" dirty="0"/>
-          </a:p>
-        </p:txBody>
-      </p:sp>
-      <p:sp>
-        <p:nvSpPr>
-          <p:cNvPr id="8" name="Shape 6"/>
-          <p:cNvSpPr/>
-          <p:nvPr/>
-        </p:nvSpPr>
-        <p:spPr>
-          <a:xfrm>
-            <a:off x="4398264" y="2331720"/>
-            <a:ext cx="3429000" cy="2926080"/>
-          </a:xfrm>
-          <a:prstGeom prst="roundRect">
-            <a:avLst>
-              <a:gd name="adj" fmla="val 2500"/>
-            </a:avLst>
-          </a:prstGeom>
-          <a:solidFill>
-            <a:srgbClr val="C8102E"/>
-          </a:solidFill>
-          <a:ln w="12700">
-            <a:solidFill>
-              <a:srgbClr val="C8102E"/>
-            </a:solidFill>
-            <a:prstDash val="solid"/>
-          </a:ln>
-        </p:spPr>
-      </p:sp>
-      <p:sp>
-        <p:nvSpPr>
-          <p:cNvPr id="9" name="Text 7"/>
-          <p:cNvSpPr/>
-          <p:nvPr/>
-        </p:nvSpPr>
-        <p:spPr>
-          <a:xfrm>
-            <a:off x="4718304" y="2697480"/>
-            <a:ext cx="2788920" cy="320040"/>
-          </a:xfrm>
-          <a:prstGeom prst="rect">
-            <a:avLst/>
-          </a:prstGeom>
-          <a:noFill/>
-          <a:ln/>
-        </p:spPr>
-        <p:txBody>
-          <a:bodyPr wrap="square" lIns="0" tIns="0" rIns="0" bIns="0" rtlCol="0" anchor="ctr"/>
-          <a:lstStyle/>
-          <a:p>
-            <a:pPr indent="0" marL="0">
-              <a:buNone/>
-            </a:pPr>
-            <a:r>
-              <a:rPr lang="en-US" sz="1050" b="1" spc="200" kern="0" dirty="0">
-                <a:solidFill>
-                  <a:srgbClr val="F3C2CB"/>
-                </a:solidFill>
-                <a:latin typeface="Calibri" pitchFamily="34" charset="0"/>
-                <a:ea typeface="Calibri" pitchFamily="34" charset="-122"/>
-                <a:cs typeface="Calibri" pitchFamily="34" charset="-120"/>
-              </a:rPr>
-              <a:t>SEMI-FINAL — 7 SEP</a:t>
-            </a:r>
-            <a:endParaRPr lang="en-US" sz="1050" dirty="0"/>
-          </a:p>
-        </p:txBody>
-      </p:sp>
-      <p:sp>
-        <p:nvSpPr>
-          <p:cNvPr id="10" name="Text 8"/>
-          <p:cNvSpPr/>
-          <p:nvPr/>
-        </p:nvSpPr>
-        <p:spPr>
-          <a:xfrm>
-            <a:off x="4718304" y="3063240"/>
-            <a:ext cx="2788920" cy="777240"/>
-          </a:xfrm>
-          <a:prstGeom prst="rect">
-            <a:avLst/>
-          </a:prstGeom>
-          <a:noFill/>
-          <a:ln/>
-        </p:spPr>
-        <p:txBody>
-          <a:bodyPr wrap="square" lIns="0" tIns="0" rIns="0" bIns="0" rtlCol="0" anchor="ctr"/>
-          <a:lstStyle/>
-          <a:p>
-            <a:pPr indent="0" marL="0">
-              <a:buNone/>
-            </a:pPr>
-            <a:r>
-              <a:rPr lang="en-US" sz="1900" b="1" dirty="0">
-                <a:solidFill>
-                  <a:srgbClr val="F5F7FA"/>
-                </a:solidFill>
-                <a:latin typeface="Cambria" pitchFamily="34" charset="0"/>
-                <a:ea typeface="Cambria" pitchFamily="34" charset="-122"/>
-                <a:cs typeface="Cambria" pitchFamily="34" charset="-120"/>
-              </a:rPr>
-              <a:t>Results &amp; evidence</a:t>
-            </a:r>
-            <a:endParaRPr lang="en-US" sz="1900" dirty="0"/>
-          </a:p>
-        </p:txBody>
-      </p:sp>
-      <p:sp>
-        <p:nvSpPr>
-          <p:cNvPr id="11" name="Text 9"/>
-          <p:cNvSpPr/>
-          <p:nvPr/>
-        </p:nvSpPr>
-        <p:spPr>
-          <a:xfrm>
-            <a:off x="4718304" y="3886200"/>
-            <a:ext cx="2788920" cy="1234440"/>
-          </a:xfrm>
-          <a:prstGeom prst="rect">
-            <a:avLst/>
-          </a:prstGeom>
-          <a:noFill/>
-          <a:ln/>
-        </p:spPr>
-        <p:txBody>
-          <a:bodyPr wrap="square" lIns="0" tIns="0" rIns="0" bIns="0" rtlCol="0" anchor="ctr"/>
-          <a:lstStyle/>
-          <a:p>
-            <a:pPr indent="0" marL="0">
-              <a:lnSpc>
-                <a:spcPct val="120000"/>
-              </a:lnSpc>
-              <a:buNone/>
-            </a:pPr>
-            <a:r>
-              <a:rPr lang="en-US" sz="1150" dirty="0">
-                <a:solidFill>
-                  <a:srgbClr val="F3D9DD"/>
-                </a:solidFill>
-                <a:latin typeface="Calibri" pitchFamily="34" charset="0"/>
-                <a:ea typeface="Calibri" pitchFamily="34" charset="-122"/>
-                <a:cs typeface="Calibri" pitchFamily="34" charset="-120"/>
-              </a:rPr>
-              <a:t>the FY2025 numbers, accuracy against withheld years, inventory trade-off, refinements from your feedback</a:t>
-            </a:r>
-            <a:endParaRPr lang="en-US" sz="1150" dirty="0"/>
-          </a:p>
-        </p:txBody>
-      </p:sp>
-      <p:sp>
-        <p:nvSpPr>
-          <p:cNvPr id="12" name="Shape 10"/>
-          <p:cNvSpPr/>
-          <p:nvPr/>
-        </p:nvSpPr>
-        <p:spPr>
-          <a:xfrm>
-            <a:off x="8110728" y="2331720"/>
-            <a:ext cx="3429000" cy="2926080"/>
-          </a:xfrm>
-          <a:prstGeom prst="roundRect">
-            <a:avLst>
-              <a:gd name="adj" fmla="val 2500"/>
-            </a:avLst>
-          </a:prstGeom>
-          <a:solidFill>
-            <a:srgbClr val="1C2530"/>
-          </a:solidFill>
-          <a:ln w="12700">
-            <a:solidFill>
-              <a:srgbClr val="1C2530"/>
-            </a:solidFill>
-            <a:prstDash val="solid"/>
-          </a:ln>
-        </p:spPr>
-      </p:sp>
-      <p:sp>
-        <p:nvSpPr>
-          <p:cNvPr id="13" name="Text 11"/>
-          <p:cNvSpPr/>
-          <p:nvPr/>
-        </p:nvSpPr>
-        <p:spPr>
-          <a:xfrm>
-            <a:off x="8430768" y="2697480"/>
-            <a:ext cx="2788920" cy="320040"/>
-          </a:xfrm>
-          <a:prstGeom prst="rect">
-            <a:avLst/>
-          </a:prstGeom>
-          <a:noFill/>
-          <a:ln/>
-        </p:spPr>
-        <p:txBody>
-          <a:bodyPr wrap="square" lIns="0" tIns="0" rIns="0" bIns="0" rtlCol="0" anchor="ctr"/>
-          <a:lstStyle/>
-          <a:p>
-            <a:pPr indent="0" marL="0">
-              <a:buNone/>
-            </a:pPr>
-            <a:r>
-              <a:rPr lang="en-US" sz="1050" b="1" spc="200" kern="0" dirty="0">
-                <a:solidFill>
-                  <a:srgbClr val="9AA4B0"/>
-                </a:solidFill>
-                <a:latin typeface="Calibri" pitchFamily="34" charset="0"/>
-                <a:ea typeface="Calibri" pitchFamily="34" charset="-122"/>
-                <a:cs typeface="Calibri" pitchFamily="34" charset="-120"/>
-              </a:rPr>
-              <a:t>FINAL — 28 SEP</a:t>
-            </a:r>
-            <a:endParaRPr lang="en-US" sz="1050" dirty="0"/>
-          </a:p>
-        </p:txBody>
-      </p:sp>
-      <p:sp>
-        <p:nvSpPr>
-          <p:cNvPr id="14" name="Text 12"/>
-          <p:cNvSpPr/>
-          <p:nvPr/>
-        </p:nvSpPr>
-        <p:spPr>
-          <a:xfrm>
-            <a:off x="8430768" y="3063240"/>
-            <a:ext cx="2788920" cy="777240"/>
-          </a:xfrm>
-          <a:prstGeom prst="rect">
-            <a:avLst/>
-          </a:prstGeom>
-          <a:noFill/>
-          <a:ln/>
-        </p:spPr>
-        <p:txBody>
-          <a:bodyPr wrap="square" lIns="0" tIns="0" rIns="0" bIns="0" rtlCol="0" anchor="ctr"/>
-          <a:lstStyle/>
-          <a:p>
-            <a:pPr indent="0" marL="0">
-              <a:buNone/>
-            </a:pPr>
-            <a:r>
-              <a:rPr lang="en-US" sz="1900" b="1" dirty="0">
-                <a:solidFill>
-                  <a:srgbClr val="F5F7FA"/>
-                </a:solidFill>
-                <a:latin typeface="Cambria" pitchFamily="34" charset="0"/>
-                <a:ea typeface="Cambria" pitchFamily="34" charset="-122"/>
-                <a:cs typeface="Cambria" pitchFamily="34" charset="-120"/>
-              </a:rPr>
-              <a:t>Final forecast &amp; handover</a:t>
-            </a:r>
-            <a:endParaRPr lang="en-US" sz="1900" dirty="0"/>
-          </a:p>
-        </p:txBody>
-      </p:sp>
-      <p:sp>
-        <p:nvSpPr>
-          <p:cNvPr id="15" name="Text 13"/>
-          <p:cNvSpPr/>
-          <p:nvPr/>
-        </p:nvSpPr>
-        <p:spPr>
-          <a:xfrm>
-            <a:off x="8430768" y="3886200"/>
-            <a:ext cx="2788920" cy="1234440"/>
-          </a:xfrm>
-          <a:prstGeom prst="rect">
-            <a:avLst/>
-          </a:prstGeom>
-          <a:noFill/>
-          <a:ln/>
-        </p:spPr>
-        <p:txBody>
-          <a:bodyPr wrap="square" lIns="0" tIns="0" rIns="0" bIns="0" rtlCol="0" anchor="ctr"/>
-          <a:lstStyle/>
-          <a:p>
-            <a:pPr indent="0" marL="0">
-              <a:lnSpc>
-                <a:spcPct val="120000"/>
-              </a:lnSpc>
-              <a:buNone/>
-            </a:pPr>
-            <a:r>
-              <a:rPr lang="en-US" sz="1150" dirty="0">
-                <a:solidFill>
-                  <a:srgbClr val="C9D2DB"/>
-                </a:solidFill>
-                <a:latin typeface="Calibri" pitchFamily="34" charset="0"/>
-                <a:ea typeface="Calibri" pitchFamily="34" charset="-122"/>
-                <a:cs typeface="Calibri" pitchFamily="34" charset="-120"/>
-              </a:rPr>
-              <a:t>final forecast with full written report, documented assumptions, and the dashboard handed over</a:t>
-            </a:r>
-            <a:endParaRPr lang="en-US" sz="1150" dirty="0"/>
-          </a:p>
-        </p:txBody>
-      </p:sp>
-      <p:sp>
-        <p:nvSpPr>
-          <p:cNvPr id="16" name="Text 14"/>
-          <p:cNvSpPr/>
-          <p:nvPr/>
-        </p:nvSpPr>
-        <p:spPr>
-          <a:xfrm>
-            <a:off x="685800" y="5760720"/>
-            <a:ext cx="10817352" cy="548640"/>
-          </a:xfrm>
-          <a:prstGeom prst="rect">
-            <a:avLst/>
-          </a:prstGeom>
-          <a:noFill/>
-          <a:ln/>
-        </p:spPr>
-        <p:txBody>
-          <a:bodyPr wrap="square" lIns="0" tIns="0" rIns="0" bIns="0" rtlCol="0" anchor="ctr"/>
-          <a:lstStyle/>
-          <a:p>
-            <a:pPr indent="0" marL="0">
-              <a:buNone/>
-            </a:pPr>
-            <a:r>
-              <a:rPr lang="en-US" sz="1250" i="1" dirty="0">
-                <a:solidFill>
-                  <a:srgbClr val="6B7280"/>
-                </a:solidFill>
-                <a:latin typeface="Calibri" pitchFamily="34" charset="0"/>
-                <a:ea typeface="Calibri" pitchFamily="34" charset="-122"/>
-                <a:cs typeface="Calibri" pitchFamily="34" charset="-120"/>
-              </a:rPr>
-              <a:t>Between milestones: sales-input channel for the event-driven products, monthly re-forecast rhythm, and refinements from today’s discussion.</a:t>
-            </a:r>
-            <a:endParaRPr lang="en-US" sz="1250" dirty="0"/>
-          </a:p>
-        </p:txBody>
-      </p:sp>
-    </p:spTree>
-  </p:cSld>
-  <p:clrMapOvr>
-    <a:masterClrMapping/>
-  </p:clrMapOvr>
-</p:sld>
-</file>
-
-<file path=ppt/slides/slide11.xml><?xml version="1.0" encoding="utf-8"?>
-<p:sld xmlns:a="http://schemas.openxmlformats.org/drawingml/2006/main" xmlns:r="http://schemas.openxmlformats.org/officeDocument/2006/relationships" xmlns:p="http://schemas.openxmlformats.org/presentationml/2006/main">
-  <p:cSld name="Slide 11">
-    <p:bg>
-      <p:bgPr>
-        <a:solidFill>
           <a:srgbClr val="1C2530"/>
         </a:solidFill>
       </p:bgPr>
@@ -5939,7 +5260,7 @@
                 <a:ea typeface="Calibri" pitchFamily="34" charset="-122"/>
                 <a:cs typeface="Calibri" pitchFamily="34" charset="-120"/>
               </a:rPr>
-              <a:t>Live demonstration available after the presentation.</a:t>
+              <a:t>Demonstrated live in a moment — on the real data.</a:t>
             </a:r>
             <a:endParaRPr lang="en-US" sz="1250" dirty="0"/>
           </a:p>
@@ -6471,7 +5792,7 @@
                 <a:ea typeface="Calibri" pitchFamily="34" charset="-122"/>
                 <a:cs typeface="Calibri" pitchFamily="34" charset="-120"/>
               </a:rPr>
-              <a:t>08 — FOUND IN THE FINE PRINT</a:t>
+              <a:t>09 — THE ROAD AHEAD</a:t>
             </a:r>
             <a:endParaRPr lang="en-US" sz="1050" dirty="0"/>
           </a:p>
@@ -6510,7 +5831,7 @@
                 <a:ea typeface="Cambria" pitchFamily="34" charset="-122"/>
                 <a:cs typeface="Cambria" pitchFamily="34" charset="-120"/>
               </a:rPr>
-              <a:t>Two findings from careful reading.</a:t>
+              <a:t>Two milestones to the final forecast.</a:t>
             </a:r>
             <a:endParaRPr lang="en-US" sz="3800" dirty="0"/>
           </a:p>
@@ -6518,212 +5839,413 @@
       </p:sp>
       <p:sp>
         <p:nvSpPr>
-          <p:cNvPr id="4" name="Text 2"/>
-          <p:cNvSpPr/>
-          <p:nvPr/>
-        </p:nvSpPr>
-        <p:spPr>
-          <a:xfrm>
-            <a:off x="685800" y="2386584"/>
-            <a:ext cx="1417320" cy="320040"/>
-          </a:xfrm>
-          <a:prstGeom prst="rect">
-            <a:avLst/>
-          </a:prstGeom>
-          <a:noFill/>
-          <a:ln/>
-        </p:spPr>
-        <p:txBody>
-          <a:bodyPr wrap="square" lIns="0" tIns="0" rIns="0" bIns="0" rtlCol="0" anchor="ctr"/>
-          <a:lstStyle/>
-          <a:p>
-            <a:pPr indent="0" marL="0">
-              <a:buNone/>
-            </a:pPr>
-            <a:r>
-              <a:rPr lang="en-US" sz="1100" b="1" spc="200" kern="0" dirty="0">
-                <a:solidFill>
-                  <a:srgbClr val="6B7280"/>
+          <p:cNvPr id="4" name="Shape 2"/>
+          <p:cNvSpPr/>
+          <p:nvPr/>
+        </p:nvSpPr>
+        <p:spPr>
+          <a:xfrm>
+            <a:off x="685800" y="2331720"/>
+            <a:ext cx="3429000" cy="2926080"/>
+          </a:xfrm>
+          <a:prstGeom prst="roundRect">
+            <a:avLst>
+              <a:gd name="adj" fmla="val 2500"/>
+            </a:avLst>
+          </a:prstGeom>
+          <a:solidFill>
+            <a:srgbClr val="1C2530"/>
+          </a:solidFill>
+          <a:ln w="12700">
+            <a:solidFill>
+              <a:srgbClr val="1C2530"/>
+            </a:solidFill>
+            <a:prstDash val="solid"/>
+          </a:ln>
+        </p:spPr>
+      </p:sp>
+      <p:sp>
+        <p:nvSpPr>
+          <p:cNvPr id="5" name="Text 3"/>
+          <p:cNvSpPr/>
+          <p:nvPr/>
+        </p:nvSpPr>
+        <p:spPr>
+          <a:xfrm>
+            <a:off x="1005840" y="2697480"/>
+            <a:ext cx="2788920" cy="320040"/>
+          </a:xfrm>
+          <a:prstGeom prst="rect">
+            <a:avLst/>
+          </a:prstGeom>
+          <a:noFill/>
+          <a:ln/>
+        </p:spPr>
+        <p:txBody>
+          <a:bodyPr wrap="square" lIns="0" tIns="0" rIns="0" bIns="0" rtlCol="0" anchor="ctr"/>
+          <a:lstStyle/>
+          <a:p>
+            <a:pPr indent="0" marL="0">
+              <a:buNone/>
+            </a:pPr>
+            <a:r>
+              <a:rPr lang="en-US" sz="1050" b="1" spc="200" kern="0" dirty="0">
+                <a:solidFill>
+                  <a:srgbClr val="9AA4B0"/>
                 </a:solidFill>
                 <a:latin typeface="Calibri" pitchFamily="34" charset="0"/>
                 <a:ea typeface="Calibri" pitchFamily="34" charset="-122"/>
                 <a:cs typeface="Calibri" pitchFamily="34" charset="-120"/>
               </a:rPr>
-              <a:t>RESOLVED</a:t>
-            </a:r>
-            <a:endParaRPr lang="en-US" sz="1100" dirty="0"/>
-          </a:p>
-        </p:txBody>
-      </p:sp>
-      <p:sp>
-        <p:nvSpPr>
-          <p:cNvPr id="5" name="Text 3"/>
-          <p:cNvSpPr/>
-          <p:nvPr/>
-        </p:nvSpPr>
-        <p:spPr>
-          <a:xfrm>
-            <a:off x="2331720" y="2331720"/>
-            <a:ext cx="8778240" cy="411480"/>
-          </a:xfrm>
-          <a:prstGeom prst="rect">
-            <a:avLst/>
-          </a:prstGeom>
-          <a:noFill/>
-          <a:ln/>
-        </p:spPr>
-        <p:txBody>
-          <a:bodyPr wrap="square" lIns="0" tIns="0" rIns="0" bIns="0" rtlCol="0" anchor="ctr"/>
-          <a:lstStyle/>
-          <a:p>
-            <a:pPr indent="0" marL="0">
-              <a:buNone/>
-            </a:pPr>
-            <a:r>
-              <a:rPr lang="en-US" sz="1550" b="1" dirty="0">
-                <a:solidFill>
-                  <a:srgbClr val="1C2530"/>
+              <a:t>TODAY — 10 AUG</a:t>
+            </a:r>
+            <a:endParaRPr lang="en-US" sz="1050" dirty="0"/>
+          </a:p>
+        </p:txBody>
+      </p:sp>
+      <p:sp>
+        <p:nvSpPr>
+          <p:cNvPr id="6" name="Text 4"/>
+          <p:cNvSpPr/>
+          <p:nvPr/>
+        </p:nvSpPr>
+        <p:spPr>
+          <a:xfrm>
+            <a:off x="1005840" y="3063240"/>
+            <a:ext cx="2788920" cy="777240"/>
+          </a:xfrm>
+          <a:prstGeom prst="rect">
+            <a:avLst/>
+          </a:prstGeom>
+          <a:noFill/>
+          <a:ln/>
+        </p:spPr>
+        <p:txBody>
+          <a:bodyPr wrap="square" lIns="0" tIns="0" rIns="0" bIns="0" rtlCol="0" anchor="ctr"/>
+          <a:lstStyle/>
+          <a:p>
+            <a:pPr indent="0" marL="0">
+              <a:buNone/>
+            </a:pPr>
+            <a:r>
+              <a:rPr lang="en-US" sz="1900" b="1" dirty="0">
+                <a:solidFill>
+                  <a:srgbClr val="F5F7FA"/>
+                </a:solidFill>
+                <a:latin typeface="Cambria" pitchFamily="34" charset="0"/>
+                <a:ea typeface="Cambria" pitchFamily="34" charset="-122"/>
+                <a:cs typeface="Cambria" pitchFamily="34" charset="-120"/>
+              </a:rPr>
+              <a:t>Progress report</a:t>
+            </a:r>
+            <a:endParaRPr lang="en-US" sz="1900" dirty="0"/>
+          </a:p>
+        </p:txBody>
+      </p:sp>
+      <p:sp>
+        <p:nvSpPr>
+          <p:cNvPr id="7" name="Text 5"/>
+          <p:cNvSpPr/>
+          <p:nvPr/>
+        </p:nvSpPr>
+        <p:spPr>
+          <a:xfrm>
+            <a:off x="1005840" y="3886200"/>
+            <a:ext cx="2788920" cy="1234440"/>
+          </a:xfrm>
+          <a:prstGeom prst="rect">
+            <a:avLst/>
+          </a:prstGeom>
+          <a:noFill/>
+          <a:ln/>
+        </p:spPr>
+        <p:txBody>
+          <a:bodyPr wrap="square" lIns="0" tIns="0" rIns="0" bIns="0" rtlCol="0" anchor="ctr"/>
+          <a:lstStyle/>
+          <a:p>
+            <a:pPr indent="0" marL="0">
+              <a:lnSpc>
+                <a:spcPct val="120000"/>
+              </a:lnSpc>
+              <a:buNone/>
+            </a:pPr>
+            <a:r>
+              <a:rPr lang="en-US" sz="1150" dirty="0">
+                <a:solidFill>
+                  <a:srgbClr val="C9D2DB"/>
                 </a:solidFill>
                 <a:latin typeface="Calibri" pitchFamily="34" charset="0"/>
                 <a:ea typeface="Calibri" pitchFamily="34" charset="-122"/>
                 <a:cs typeface="Calibri" pitchFamily="34" charset="-120"/>
               </a:rPr>
-              <a:t>“Closed” orders are cancelled work</a:t>
-            </a:r>
-            <a:endParaRPr lang="en-US" sz="1550" dirty="0"/>
-          </a:p>
-        </p:txBody>
-      </p:sp>
-      <p:sp>
-        <p:nvSpPr>
-          <p:cNvPr id="6" name="Text 4"/>
-          <p:cNvSpPr/>
-          <p:nvPr/>
-        </p:nvSpPr>
-        <p:spPr>
-          <a:xfrm>
-            <a:off x="2331720" y="2788920"/>
-            <a:ext cx="8778240" cy="868680"/>
-          </a:xfrm>
-          <a:prstGeom prst="rect">
-            <a:avLst/>
-          </a:prstGeom>
-          <a:noFill/>
-          <a:ln/>
-        </p:spPr>
-        <p:txBody>
-          <a:bodyPr wrap="square" lIns="0" tIns="0" rIns="0" bIns="0" rtlCol="0" anchor="ctr"/>
-          <a:lstStyle/>
-          <a:p>
-            <a:pPr indent="0" marL="0">
-              <a:lnSpc>
-                <a:spcPct val="115000"/>
-              </a:lnSpc>
-              <a:buNone/>
-            </a:pPr>
-            <a:r>
-              <a:rPr lang="en-US" sz="1200" dirty="0">
-                <a:solidFill>
-                  <a:srgbClr val="6B7280"/>
+              <a:t>system built and running; data understood; questions raised</a:t>
+            </a:r>
+            <a:endParaRPr lang="en-US" sz="1150" dirty="0"/>
+          </a:p>
+        </p:txBody>
+      </p:sp>
+      <p:sp>
+        <p:nvSpPr>
+          <p:cNvPr id="8" name="Shape 6"/>
+          <p:cNvSpPr/>
+          <p:nvPr/>
+        </p:nvSpPr>
+        <p:spPr>
+          <a:xfrm>
+            <a:off x="4398264" y="2331720"/>
+            <a:ext cx="3429000" cy="2926080"/>
+          </a:xfrm>
+          <a:prstGeom prst="roundRect">
+            <a:avLst>
+              <a:gd name="adj" fmla="val 2500"/>
+            </a:avLst>
+          </a:prstGeom>
+          <a:solidFill>
+            <a:srgbClr val="C8102E"/>
+          </a:solidFill>
+          <a:ln w="12700">
+            <a:solidFill>
+              <a:srgbClr val="C8102E"/>
+            </a:solidFill>
+            <a:prstDash val="solid"/>
+          </a:ln>
+        </p:spPr>
+      </p:sp>
+      <p:sp>
+        <p:nvSpPr>
+          <p:cNvPr id="9" name="Text 7"/>
+          <p:cNvSpPr/>
+          <p:nvPr/>
+        </p:nvSpPr>
+        <p:spPr>
+          <a:xfrm>
+            <a:off x="4718304" y="2697480"/>
+            <a:ext cx="2788920" cy="320040"/>
+          </a:xfrm>
+          <a:prstGeom prst="rect">
+            <a:avLst/>
+          </a:prstGeom>
+          <a:noFill/>
+          <a:ln/>
+        </p:spPr>
+        <p:txBody>
+          <a:bodyPr wrap="square" lIns="0" tIns="0" rIns="0" bIns="0" rtlCol="0" anchor="ctr"/>
+          <a:lstStyle/>
+          <a:p>
+            <a:pPr indent="0" marL="0">
+              <a:buNone/>
+            </a:pPr>
+            <a:r>
+              <a:rPr lang="en-US" sz="1050" b="1" spc="200" kern="0" dirty="0">
+                <a:solidFill>
+                  <a:srgbClr val="F3C2CB"/>
                 </a:solidFill>
                 <a:latin typeface="Calibri" pitchFamily="34" charset="0"/>
                 <a:ea typeface="Calibri" pitchFamily="34" charset="-122"/>
                 <a:cs typeface="Calibri" pitchFamily="34" charset="-120"/>
               </a:rPr>
-              <a:t>the authoritative dictionary sheet: closed orders are never fulfilled or billed — they count as expressed demand for stock planning, never as revenue</a:t>
-            </a:r>
-            <a:endParaRPr lang="en-US" sz="1200" dirty="0"/>
-          </a:p>
-        </p:txBody>
-      </p:sp>
-      <p:sp>
-        <p:nvSpPr>
-          <p:cNvPr id="7" name="Text 5"/>
-          <p:cNvSpPr/>
-          <p:nvPr/>
-        </p:nvSpPr>
-        <p:spPr>
-          <a:xfrm>
-            <a:off x="685800" y="3986784"/>
-            <a:ext cx="1417320" cy="320040"/>
-          </a:xfrm>
-          <a:prstGeom prst="rect">
-            <a:avLst/>
-          </a:prstGeom>
-          <a:noFill/>
-          <a:ln/>
-        </p:spPr>
-        <p:txBody>
-          <a:bodyPr wrap="square" lIns="0" tIns="0" rIns="0" bIns="0" rtlCol="0" anchor="ctr"/>
-          <a:lstStyle/>
-          <a:p>
-            <a:pPr indent="0" marL="0">
-              <a:buNone/>
-            </a:pPr>
-            <a:r>
-              <a:rPr lang="en-US" sz="1100" b="1" spc="200" kern="0" dirty="0">
-                <a:solidFill>
-                  <a:srgbClr val="C8102E"/>
+              <a:t>SEMI-FINAL — 7 SEP</a:t>
+            </a:r>
+            <a:endParaRPr lang="en-US" sz="1050" dirty="0"/>
+          </a:p>
+        </p:txBody>
+      </p:sp>
+      <p:sp>
+        <p:nvSpPr>
+          <p:cNvPr id="10" name="Text 8"/>
+          <p:cNvSpPr/>
+          <p:nvPr/>
+        </p:nvSpPr>
+        <p:spPr>
+          <a:xfrm>
+            <a:off x="4718304" y="3063240"/>
+            <a:ext cx="2788920" cy="777240"/>
+          </a:xfrm>
+          <a:prstGeom prst="rect">
+            <a:avLst/>
+          </a:prstGeom>
+          <a:noFill/>
+          <a:ln/>
+        </p:spPr>
+        <p:txBody>
+          <a:bodyPr wrap="square" lIns="0" tIns="0" rIns="0" bIns="0" rtlCol="0" anchor="ctr"/>
+          <a:lstStyle/>
+          <a:p>
+            <a:pPr indent="0" marL="0">
+              <a:buNone/>
+            </a:pPr>
+            <a:r>
+              <a:rPr lang="en-US" sz="1900" b="1" dirty="0">
+                <a:solidFill>
+                  <a:srgbClr val="F5F7FA"/>
+                </a:solidFill>
+                <a:latin typeface="Cambria" pitchFamily="34" charset="0"/>
+                <a:ea typeface="Cambria" pitchFamily="34" charset="-122"/>
+                <a:cs typeface="Cambria" pitchFamily="34" charset="-120"/>
+              </a:rPr>
+              <a:t>Results &amp; evidence</a:t>
+            </a:r>
+            <a:endParaRPr lang="en-US" sz="1900" dirty="0"/>
+          </a:p>
+        </p:txBody>
+      </p:sp>
+      <p:sp>
+        <p:nvSpPr>
+          <p:cNvPr id="11" name="Text 9"/>
+          <p:cNvSpPr/>
+          <p:nvPr/>
+        </p:nvSpPr>
+        <p:spPr>
+          <a:xfrm>
+            <a:off x="4718304" y="3886200"/>
+            <a:ext cx="2788920" cy="1234440"/>
+          </a:xfrm>
+          <a:prstGeom prst="rect">
+            <a:avLst/>
+          </a:prstGeom>
+          <a:noFill/>
+          <a:ln/>
+        </p:spPr>
+        <p:txBody>
+          <a:bodyPr wrap="square" lIns="0" tIns="0" rIns="0" bIns="0" rtlCol="0" anchor="ctr"/>
+          <a:lstStyle/>
+          <a:p>
+            <a:pPr indent="0" marL="0">
+              <a:lnSpc>
+                <a:spcPct val="120000"/>
+              </a:lnSpc>
+              <a:buNone/>
+            </a:pPr>
+            <a:r>
+              <a:rPr lang="en-US" sz="1150" dirty="0">
+                <a:solidFill>
+                  <a:srgbClr val="F3D9DD"/>
                 </a:solidFill>
                 <a:latin typeface="Calibri" pitchFamily="34" charset="0"/>
                 <a:ea typeface="Calibri" pitchFamily="34" charset="-122"/>
                 <a:cs typeface="Calibri" pitchFamily="34" charset="-120"/>
               </a:rPr>
-              <a:t>OPEN</a:t>
-            </a:r>
-            <a:endParaRPr lang="en-US" sz="1100" dirty="0"/>
-          </a:p>
-        </p:txBody>
-      </p:sp>
-      <p:sp>
-        <p:nvSpPr>
-          <p:cNvPr id="8" name="Text 6"/>
-          <p:cNvSpPr/>
-          <p:nvPr/>
-        </p:nvSpPr>
-        <p:spPr>
-          <a:xfrm>
-            <a:off x="2331720" y="3931920"/>
-            <a:ext cx="8778240" cy="411480"/>
-          </a:xfrm>
-          <a:prstGeom prst="rect">
-            <a:avLst/>
-          </a:prstGeom>
-          <a:noFill/>
-          <a:ln/>
-        </p:spPr>
-        <p:txBody>
-          <a:bodyPr wrap="square" lIns="0" tIns="0" rIns="0" bIns="0" rtlCol="0" anchor="ctr"/>
-          <a:lstStyle/>
-          <a:p>
-            <a:pPr indent="0" marL="0">
-              <a:buNone/>
-            </a:pPr>
-            <a:r>
-              <a:rPr lang="en-US" sz="1550" b="1" dirty="0">
-                <a:solidFill>
-                  <a:srgbClr val="1C2530"/>
+              <a:t>the FY2025 numbers, accuracy against withheld years, inventory trade-off, refinements from your feedback</a:t>
+            </a:r>
+            <a:endParaRPr lang="en-US" sz="1150" dirty="0"/>
+          </a:p>
+        </p:txBody>
+      </p:sp>
+      <p:sp>
+        <p:nvSpPr>
+          <p:cNvPr id="12" name="Shape 10"/>
+          <p:cNvSpPr/>
+          <p:nvPr/>
+        </p:nvSpPr>
+        <p:spPr>
+          <a:xfrm>
+            <a:off x="8110728" y="2331720"/>
+            <a:ext cx="3429000" cy="2926080"/>
+          </a:xfrm>
+          <a:prstGeom prst="roundRect">
+            <a:avLst>
+              <a:gd name="adj" fmla="val 2500"/>
+            </a:avLst>
+          </a:prstGeom>
+          <a:solidFill>
+            <a:srgbClr val="1C2530"/>
+          </a:solidFill>
+          <a:ln w="12700">
+            <a:solidFill>
+              <a:srgbClr val="1C2530"/>
+            </a:solidFill>
+            <a:prstDash val="solid"/>
+          </a:ln>
+        </p:spPr>
+      </p:sp>
+      <p:sp>
+        <p:nvSpPr>
+          <p:cNvPr id="13" name="Text 11"/>
+          <p:cNvSpPr/>
+          <p:nvPr/>
+        </p:nvSpPr>
+        <p:spPr>
+          <a:xfrm>
+            <a:off x="8430768" y="2697480"/>
+            <a:ext cx="2788920" cy="320040"/>
+          </a:xfrm>
+          <a:prstGeom prst="rect">
+            <a:avLst/>
+          </a:prstGeom>
+          <a:noFill/>
+          <a:ln/>
+        </p:spPr>
+        <p:txBody>
+          <a:bodyPr wrap="square" lIns="0" tIns="0" rIns="0" bIns="0" rtlCol="0" anchor="ctr"/>
+          <a:lstStyle/>
+          <a:p>
+            <a:pPr indent="0" marL="0">
+              <a:buNone/>
+            </a:pPr>
+            <a:r>
+              <a:rPr lang="en-US" sz="1050" b="1" spc="200" kern="0" dirty="0">
+                <a:solidFill>
+                  <a:srgbClr val="9AA4B0"/>
                 </a:solidFill>
                 <a:latin typeface="Calibri" pitchFamily="34" charset="0"/>
                 <a:ea typeface="Calibri" pitchFamily="34" charset="-122"/>
                 <a:cs typeface="Calibri" pitchFamily="34" charset="-120"/>
               </a:rPr>
-              <a:t>The VIP discount is not inside Base Price</a:t>
-            </a:r>
-            <a:endParaRPr lang="en-US" sz="1550" dirty="0"/>
-          </a:p>
-        </p:txBody>
-      </p:sp>
-      <p:sp>
-        <p:nvSpPr>
-          <p:cNvPr id="9" name="Text 7"/>
-          <p:cNvSpPr/>
-          <p:nvPr/>
-        </p:nvSpPr>
-        <p:spPr>
-          <a:xfrm>
-            <a:off x="2331720" y="4389120"/>
-            <a:ext cx="8778240" cy="868680"/>
+              <a:t>FINAL — 28 SEP</a:t>
+            </a:r>
+            <a:endParaRPr lang="en-US" sz="1050" dirty="0"/>
+          </a:p>
+        </p:txBody>
+      </p:sp>
+      <p:sp>
+        <p:nvSpPr>
+          <p:cNvPr id="14" name="Text 12"/>
+          <p:cNvSpPr/>
+          <p:nvPr/>
+        </p:nvSpPr>
+        <p:spPr>
+          <a:xfrm>
+            <a:off x="8430768" y="3063240"/>
+            <a:ext cx="2788920" cy="777240"/>
+          </a:xfrm>
+          <a:prstGeom prst="rect">
+            <a:avLst/>
+          </a:prstGeom>
+          <a:noFill/>
+          <a:ln/>
+        </p:spPr>
+        <p:txBody>
+          <a:bodyPr wrap="square" lIns="0" tIns="0" rIns="0" bIns="0" rtlCol="0" anchor="ctr"/>
+          <a:lstStyle/>
+          <a:p>
+            <a:pPr indent="0" marL="0">
+              <a:buNone/>
+            </a:pPr>
+            <a:r>
+              <a:rPr lang="en-US" sz="1900" b="1" dirty="0">
+                <a:solidFill>
+                  <a:srgbClr val="F5F7FA"/>
+                </a:solidFill>
+                <a:latin typeface="Cambria" pitchFamily="34" charset="0"/>
+                <a:ea typeface="Cambria" pitchFamily="34" charset="-122"/>
+                <a:cs typeface="Cambria" pitchFamily="34" charset="-120"/>
+              </a:rPr>
+              <a:t>Final forecast &amp; handover</a:t>
+            </a:r>
+            <a:endParaRPr lang="en-US" sz="1900" dirty="0"/>
+          </a:p>
+        </p:txBody>
+      </p:sp>
+      <p:sp>
+        <p:nvSpPr>
+          <p:cNvPr id="15" name="Text 13"/>
+          <p:cNvSpPr/>
+          <p:nvPr/>
+        </p:nvSpPr>
+        <p:spPr>
+          <a:xfrm>
+            <a:off x="8430768" y="3886200"/>
+            <a:ext cx="2788920" cy="1234440"/>
           </a:xfrm>
           <a:prstGeom prst="rect">
             <a:avLst/>
@@ -6737,35 +6259,35 @@
           <a:p>
             <a:pPr indent="0" marL="0">
               <a:lnSpc>
-                <a:spcPct val="115000"/>
+                <a:spcPct val="120000"/>
               </a:lnSpc>
               <a:buNone/>
             </a:pPr>
             <a:r>
-              <a:rPr lang="en-US" sz="1200" dirty="0">
-                <a:solidFill>
-                  <a:srgbClr val="6B7280"/>
+              <a:rPr lang="en-US" sz="1150" dirty="0">
+                <a:solidFill>
+                  <a:srgbClr val="C9D2DB"/>
                 </a:solidFill>
                 <a:latin typeface="Calibri" pitchFamily="34" charset="0"/>
                 <a:ea typeface="Calibri" pitchFamily="34" charset="-122"/>
                 <a:cs typeface="Calibri" pitchFamily="34" charset="-120"/>
               </a:rPr>
-              <a:t>the dictionary grants VIP a 37% discount from list — yet on shared products, VIP and End User pay an identical Base Price (median ratio 1.000). The discount must be applied outside this file; ฿461m of revenue interpretation rides on Mitsubishi’s answer</a:t>
-            </a:r>
-            <a:endParaRPr lang="en-US" sz="1200" dirty="0"/>
-          </a:p>
-        </p:txBody>
-      </p:sp>
-      <p:sp>
-        <p:nvSpPr>
-          <p:cNvPr id="10" name="Text 8"/>
+              <a:t>final forecast with full written report, documented assumptions, and the dashboard handed over</a:t>
+            </a:r>
+            <a:endParaRPr lang="en-US" sz="1150" dirty="0"/>
+          </a:p>
+        </p:txBody>
+      </p:sp>
+      <p:sp>
+        <p:nvSpPr>
+          <p:cNvPr id="16" name="Text 14"/>
           <p:cNvSpPr/>
           <p:nvPr/>
         </p:nvSpPr>
         <p:spPr>
           <a:xfrm>
             <a:off x="685800" y="5760720"/>
-            <a:ext cx="10817352" cy="457200"/>
+            <a:ext cx="10817352" cy="548640"/>
           </a:xfrm>
           <a:prstGeom prst="rect">
             <a:avLst/>
@@ -6789,7 +6311,7 @@
                 <a:ea typeface="Calibri" pitchFamily="34" charset="-122"/>
                 <a:cs typeface="Calibri" pitchFamily="34" charset="-120"/>
               </a:rPr>
-              <a:t>Either answer to the pricing question takes effect through one configuration line — the system re-runs in two minutes.</a:t>
+              <a:t>Between milestones: sales-input channel for the event-driven products, monthly re-forecast rhythm, and refinements from today’s discussion.</a:t>
             </a:r>
             <a:endParaRPr lang="en-US" sz="1250" dirty="0"/>
           </a:p>

</xml_diff>